<commit_message>
Diversify the title slide too: 8 distinct slide-1 compositions across the 26
Slide 1 clustered into a few looks. Added four more title layouts for eight total
-- left-aligned, centered, split colour-block, kicker+lower-anchored, oversized
poster, right colour-block, framed panel, and two-tone horizontal field -- spread
so each deck's title reads differently, and each paired with its own topic palette
and font. Rendered all 26 title slides into a comparison grid to confirm no two
look alike. All 26 validate and render clean; 52 files re-staged in tmp/.
</commit_message>
<xml_diff>
--- a/ppt/DeekondaRakshan_X25180754_wildfire-forest-monitoring.pptx
+++ b/ppt/DeekondaRakshan_X25180754_wildfire-forest-monitoring.pptx
@@ -1598,18 +1598,18 @@
         </p:nvSpPr>
         <p:spPr>
           <a:xfrm>
-            <a:off x="640080" y="1554480"/>
-            <a:ext cx="3200400" cy="3383280"/>
+            <a:off x="3992728" y="1234440"/>
+            <a:ext cx="4206240" cy="658368"/>
           </a:xfrm>
           <a:prstGeom prst="roundRect">
             <a:avLst>
-              <a:gd name="adj" fmla="val 2857"/>
+              <a:gd name="adj" fmla="val 11111"/>
             </a:avLst>
           </a:prstGeom>
           <a:solidFill>
             <a:srgbClr val="EEF3EA"/>
           </a:solidFill>
-          <a:ln w="19050">
+          <a:ln w="17780">
             <a:solidFill>
               <a:srgbClr val="6A9A52"/>
             </a:solidFill>
@@ -1619,69 +1619,62 @@
       </p:sp>
       <p:sp>
         <p:nvSpPr>
-          <p:cNvPr id="4" name="Text 2"/>
-          <p:cNvSpPr/>
-          <p:nvPr/>
-        </p:nvSpPr>
-        <p:spPr>
-          <a:xfrm>
-            <a:off x="640080" y="1691640"/>
-            <a:ext cx="3200400" cy="365760"/>
-          </a:xfrm>
-          <a:prstGeom prst="rect">
-            <a:avLst/>
-          </a:prstGeom>
-          <a:noFill/>
-          <a:ln/>
-        </p:spPr>
-        <p:txBody>
-          <a:bodyPr wrap="square" rtlCol="0" anchor="ctr"/>
-          <a:lstStyle/>
-          <a:p>
-            <a:pPr algn="ctr" indent="0" marL="0">
-              <a:buNone/>
-            </a:pPr>
-            <a:r>
-              <a:rPr lang="en-US" sz="1200" b="1" spc="300" kern="0" dirty="0">
-                <a:solidFill>
-                  <a:srgbClr val="6A9A52"/>
+          <p:cNvPr id="4" name="Shape 2"/>
+          <p:cNvSpPr/>
+          <p:nvPr/>
+        </p:nvSpPr>
+        <p:spPr>
+          <a:xfrm>
+            <a:off x="4193896" y="1481328"/>
+            <a:ext cx="164592" cy="164592"/>
+          </a:xfrm>
+          <a:prstGeom prst="ellipse">
+            <a:avLst/>
+          </a:prstGeom>
+          <a:solidFill>
+            <a:srgbClr val="6A9A52"/>
+          </a:solidFill>
+          <a:ln/>
+        </p:spPr>
+      </p:sp>
+      <p:sp>
+        <p:nvSpPr>
+          <p:cNvPr id="5" name="Text 3"/>
+          <p:cNvSpPr/>
+          <p:nvPr/>
+        </p:nvSpPr>
+        <p:spPr>
+          <a:xfrm>
+            <a:off x="4495648" y="1234440"/>
+            <a:ext cx="2194560" cy="658368"/>
+          </a:xfrm>
+          <a:prstGeom prst="rect">
+            <a:avLst/>
+          </a:prstGeom>
+          <a:noFill/>
+          <a:ln/>
+        </p:spPr>
+        <p:txBody>
+          <a:bodyPr wrap="square" lIns="0" tIns="0" rIns="0" bIns="0" rtlCol="0" anchor="ctr"/>
+          <a:lstStyle/>
+          <a:p>
+            <a:pPr indent="0" marL="0">
+              <a:buNone/>
+            </a:pPr>
+            <a:r>
+              <a:rPr lang="en-US" sz="1350" b="1" dirty="0">
+                <a:solidFill>
+                  <a:srgbClr val="1B2418"/>
                 </a:solidFill>
                 <a:latin typeface="Calibri" pitchFamily="34" charset="0"/>
                 <a:ea typeface="Calibri" pitchFamily="34" charset="-122"/>
                 <a:cs typeface="Calibri" pitchFamily="34" charset="-120"/>
               </a:rPr>
-              <a:t>EDGE</a:t>
-            </a:r>
-            <a:endParaRPr lang="en-US" sz="1200" dirty="0"/>
-          </a:p>
-        </p:txBody>
-      </p:sp>
-      <p:sp>
-        <p:nvSpPr>
-          <p:cNvPr id="5" name="Shape 3"/>
-          <p:cNvSpPr/>
-          <p:nvPr/>
-        </p:nvSpPr>
-        <p:spPr>
-          <a:xfrm>
-            <a:off x="914400" y="2286000"/>
-            <a:ext cx="2651760" cy="1005840"/>
-          </a:xfrm>
-          <a:prstGeom prst="roundRect">
-            <a:avLst>
-              <a:gd name="adj" fmla="val 7273"/>
-            </a:avLst>
-          </a:prstGeom>
-          <a:solidFill>
-            <a:srgbClr val="FFFFFF"/>
-          </a:solidFill>
-          <a:ln w="15240">
-            <a:solidFill>
-              <a:srgbClr val="6A9A52"/>
-            </a:solidFill>
-            <a:prstDash val="solid"/>
-          </a:ln>
-        </p:spPr>
+              <a:t>Field sensors</a:t>
+            </a:r>
+            <a:endParaRPr lang="en-US" sz="1350" dirty="0"/>
+          </a:p>
+        </p:txBody>
       </p:sp>
       <p:sp>
         <p:nvSpPr>
@@ -1691,8 +1684,8 @@
         </p:nvSpPr>
         <p:spPr>
           <a:xfrm>
-            <a:off x="914400" y="2432304"/>
-            <a:ext cx="2651760" cy="365760"/>
+            <a:off x="6644488" y="1234440"/>
+            <a:ext cx="1463040" cy="658368"/>
           </a:xfrm>
           <a:prstGeom prst="rect">
             <a:avLst/>
@@ -1704,379 +1697,40 @@
           <a:bodyPr wrap="square" lIns="0" tIns="0" rIns="0" bIns="0" rtlCol="0" anchor="ctr"/>
           <a:lstStyle/>
           <a:p>
-            <a:pPr algn="ctr" indent="0" marL="0">
-              <a:buNone/>
-            </a:pPr>
-            <a:r>
-              <a:rPr lang="en-US" sz="1400" b="1" dirty="0">
-                <a:solidFill>
-                  <a:srgbClr val="1B2418"/>
+            <a:pPr algn="r" indent="0" marL="0">
+              <a:buNone/>
+            </a:pPr>
+            <a:r>
+              <a:rPr lang="en-US" sz="950" dirty="0">
+                <a:solidFill>
+                  <a:srgbClr val="5F6E55"/>
                 </a:solidFill>
                 <a:latin typeface="Calibri" pitchFamily="34" charset="0"/>
                 <a:ea typeface="Calibri" pitchFamily="34" charset="-122"/>
                 <a:cs typeface="Calibri" pitchFamily="34" charset="-120"/>
               </a:rPr>
-              <a:t>Field sensors</a:t>
-            </a:r>
-            <a:endParaRPr lang="en-US" sz="1400" dirty="0"/>
-          </a:p>
-        </p:txBody>
-      </p:sp>
-      <p:sp>
-        <p:nvSpPr>
-          <p:cNvPr id="7" name="Text 5"/>
-          <p:cNvSpPr/>
-          <p:nvPr/>
-        </p:nvSpPr>
-        <p:spPr>
-          <a:xfrm>
-            <a:off x="914400" y="2816352"/>
-            <a:ext cx="2651760" cy="365760"/>
-          </a:xfrm>
-          <a:prstGeom prst="rect">
-            <a:avLst/>
-          </a:prstGeom>
-          <a:noFill/>
-          <a:ln/>
-        </p:spPr>
-        <p:txBody>
-          <a:bodyPr wrap="square" lIns="0" tIns="0" rIns="0" bIns="0" rtlCol="0" anchor="ctr"/>
-          <a:lstStyle/>
-          <a:p>
-            <a:pPr algn="ctr" indent="0" marL="0">
-              <a:buNone/>
-            </a:pPr>
-            <a:r>
-              <a:rPr lang="en-US" sz="1000" dirty="0">
-                <a:solidFill>
-                  <a:srgbClr val="5F6E55"/>
-                </a:solidFill>
-                <a:latin typeface="Calibri" pitchFamily="34" charset="0"/>
-                <a:ea typeface="Calibri" pitchFamily="34" charset="-122"/>
-                <a:cs typeface="Calibri" pitchFamily="34" charset="-120"/>
-              </a:rPr>
               <a:t>10 · 2 stations · 5 metrics</a:t>
             </a:r>
-            <a:endParaRPr lang="en-US" sz="1000" dirty="0"/>
-          </a:p>
-        </p:txBody>
-      </p:sp>
-      <p:sp>
-        <p:nvSpPr>
-          <p:cNvPr id="8" name="Shape 6"/>
-          <p:cNvSpPr/>
-          <p:nvPr/>
-        </p:nvSpPr>
-        <p:spPr>
-          <a:xfrm>
-            <a:off x="914400" y="3520440"/>
-            <a:ext cx="2651760" cy="1005840"/>
-          </a:xfrm>
-          <a:prstGeom prst="roundRect">
-            <a:avLst>
-              <a:gd name="adj" fmla="val 7273"/>
-            </a:avLst>
-          </a:prstGeom>
-          <a:solidFill>
-            <a:srgbClr val="FFFFFF"/>
-          </a:solidFill>
-          <a:ln w="15240">
-            <a:solidFill>
-              <a:srgbClr val="6A9A52"/>
-            </a:solidFill>
-            <a:prstDash val="solid"/>
-          </a:ln>
-        </p:spPr>
-      </p:sp>
-      <p:sp>
-        <p:nvSpPr>
-          <p:cNvPr id="9" name="Text 7"/>
-          <p:cNvSpPr/>
-          <p:nvPr/>
-        </p:nvSpPr>
-        <p:spPr>
-          <a:xfrm>
-            <a:off x="914400" y="3666744"/>
-            <a:ext cx="2651760" cy="365760"/>
-          </a:xfrm>
-          <a:prstGeom prst="rect">
-            <a:avLst/>
-          </a:prstGeom>
-          <a:noFill/>
-          <a:ln/>
-        </p:spPr>
-        <p:txBody>
-          <a:bodyPr wrap="square" lIns="0" tIns="0" rIns="0" bIns="0" rtlCol="0" anchor="ctr"/>
-          <a:lstStyle/>
-          <a:p>
-            <a:pPr algn="ctr" indent="0" marL="0">
-              <a:buNone/>
-            </a:pPr>
-            <a:r>
-              <a:rPr lang="en-US" sz="1400" b="1" dirty="0">
-                <a:solidFill>
-                  <a:srgbClr val="1B2418"/>
-                </a:solidFill>
-                <a:latin typeface="Calibri" pitchFamily="34" charset="0"/>
-                <a:ea typeface="Calibri" pitchFamily="34" charset="-122"/>
-                <a:cs typeface="Calibri" pitchFamily="34" charset="-120"/>
-              </a:rPr>
-              <a:t>Fog node</a:t>
-            </a:r>
-            <a:endParaRPr lang="en-US" sz="1400" dirty="0"/>
-          </a:p>
-        </p:txBody>
-      </p:sp>
-      <p:sp>
-        <p:nvSpPr>
-          <p:cNvPr id="10" name="Text 8"/>
-          <p:cNvSpPr/>
-          <p:nvPr/>
-        </p:nvSpPr>
-        <p:spPr>
-          <a:xfrm>
-            <a:off x="914400" y="4050792"/>
-            <a:ext cx="2651760" cy="365760"/>
-          </a:xfrm>
-          <a:prstGeom prst="rect">
-            <a:avLst/>
-          </a:prstGeom>
-          <a:noFill/>
-          <a:ln/>
-        </p:spPr>
-        <p:txBody>
-          <a:bodyPr wrap="square" lIns="0" tIns="0" rIns="0" bIns="0" rtlCol="0" anchor="ctr"/>
-          <a:lstStyle/>
-          <a:p>
-            <a:pPr algn="ctr" indent="0" marL="0">
-              <a:buNone/>
-            </a:pPr>
-            <a:r>
-              <a:rPr lang="en-US" sz="1000" dirty="0">
-                <a:solidFill>
-                  <a:srgbClr val="5F6E55"/>
-                </a:solidFill>
-                <a:latin typeface="Calibri" pitchFamily="34" charset="0"/>
-                <a:ea typeface="Calibri" pitchFamily="34" charset="-122"/>
-                <a:cs typeface="Calibri" pitchFamily="34" charset="-120"/>
-              </a:rPr>
-              <a:t>windows · fire alerts</a:t>
-            </a:r>
-            <a:endParaRPr lang="en-US" sz="1000" dirty="0"/>
-          </a:p>
-        </p:txBody>
-      </p:sp>
-      <p:sp>
-        <p:nvSpPr>
-          <p:cNvPr id="11" name="Shape 9"/>
-          <p:cNvSpPr/>
-          <p:nvPr/>
-        </p:nvSpPr>
-        <p:spPr>
-          <a:xfrm>
-            <a:off x="3886200" y="3246120"/>
-            <a:ext cx="502920" cy="0"/>
+            <a:endParaRPr lang="en-US" sz="950" dirty="0"/>
+          </a:p>
+        </p:txBody>
+      </p:sp>
+      <p:sp>
+        <p:nvSpPr>
+          <p:cNvPr id="7" name="Shape 5"/>
+          <p:cNvSpPr/>
+          <p:nvPr/>
+        </p:nvSpPr>
+        <p:spPr>
+          <a:xfrm>
+            <a:off x="6095848" y="1892808"/>
+            <a:ext cx="0" cy="219456"/>
           </a:xfrm>
           <a:prstGeom prst="line">
             <a:avLst/>
           </a:prstGeom>
           <a:noFill/>
-          <a:ln w="31750">
-            <a:solidFill>
-              <a:srgbClr val="2C5F2D"/>
-            </a:solidFill>
-            <a:prstDash val="solid"/>
-            <a:tailEnd type="triangle"/>
-          </a:ln>
-        </p:spPr>
-      </p:sp>
-      <p:sp>
-        <p:nvSpPr>
-          <p:cNvPr id="12" name="Shape 10"/>
-          <p:cNvSpPr/>
-          <p:nvPr/>
-        </p:nvSpPr>
-        <p:spPr>
-          <a:xfrm>
-            <a:off x="4572000" y="1554480"/>
-            <a:ext cx="6949440" cy="3383280"/>
-          </a:xfrm>
-          <a:prstGeom prst="roundRect">
-            <a:avLst>
-              <a:gd name="adj" fmla="val 2703"/>
-            </a:avLst>
-          </a:prstGeom>
-          <a:solidFill>
-            <a:srgbClr val="EEF3EA"/>
-          </a:solidFill>
-          <a:ln w="19050">
-            <a:solidFill>
-              <a:srgbClr val="2C5F2D"/>
-            </a:solidFill>
-            <a:prstDash val="solid"/>
-          </a:ln>
-        </p:spPr>
-      </p:sp>
-      <p:sp>
-        <p:nvSpPr>
-          <p:cNvPr id="13" name="Text 11"/>
-          <p:cNvSpPr/>
-          <p:nvPr/>
-        </p:nvSpPr>
-        <p:spPr>
-          <a:xfrm>
-            <a:off x="4572000" y="1691640"/>
-            <a:ext cx="6949440" cy="365760"/>
-          </a:xfrm>
-          <a:prstGeom prst="rect">
-            <a:avLst/>
-          </a:prstGeom>
-          <a:noFill/>
-          <a:ln/>
-        </p:spPr>
-        <p:txBody>
-          <a:bodyPr wrap="square" rtlCol="0" anchor="ctr"/>
-          <a:lstStyle/>
-          <a:p>
-            <a:pPr algn="ctr" indent="0" marL="0">
-              <a:buNone/>
-            </a:pPr>
-            <a:r>
-              <a:rPr lang="en-US" sz="1200" b="1" spc="200" kern="0" dirty="0">
-                <a:solidFill>
-                  <a:srgbClr val="2C5F2D"/>
-                </a:solidFill>
-                <a:latin typeface="Calibri" pitchFamily="34" charset="0"/>
-                <a:ea typeface="Calibri" pitchFamily="34" charset="-122"/>
-                <a:cs typeface="Calibri" pitchFamily="34" charset="-120"/>
-              </a:rPr>
-              <a:t>CLOUD (serverless)</a:t>
-            </a:r>
-            <a:endParaRPr lang="en-US" sz="1200" dirty="0"/>
-          </a:p>
-        </p:txBody>
-      </p:sp>
-      <p:sp>
-        <p:nvSpPr>
-          <p:cNvPr id="14" name="Shape 12"/>
-          <p:cNvSpPr/>
-          <p:nvPr/>
-        </p:nvSpPr>
-        <p:spPr>
-          <a:xfrm>
-            <a:off x="4846320" y="2651760"/>
-            <a:ext cx="1463040" cy="1371600"/>
-          </a:xfrm>
-          <a:prstGeom prst="roundRect">
-            <a:avLst>
-              <a:gd name="adj" fmla="val 5333"/>
-            </a:avLst>
-          </a:prstGeom>
-          <a:solidFill>
-            <a:srgbClr val="FFFFFF"/>
-          </a:solidFill>
-          <a:ln w="15240">
-            <a:solidFill>
-              <a:srgbClr val="2C5F2D"/>
-            </a:solidFill>
-            <a:prstDash val="solid"/>
-          </a:ln>
-        </p:spPr>
-      </p:sp>
-      <p:sp>
-        <p:nvSpPr>
-          <p:cNvPr id="15" name="Text 13"/>
-          <p:cNvSpPr/>
-          <p:nvPr/>
-        </p:nvSpPr>
-        <p:spPr>
-          <a:xfrm>
-            <a:off x="4800600" y="2907792"/>
-            <a:ext cx="1554480" cy="457200"/>
-          </a:xfrm>
-          <a:prstGeom prst="rect">
-            <a:avLst/>
-          </a:prstGeom>
-          <a:noFill/>
-          <a:ln/>
-        </p:spPr>
-        <p:txBody>
-          <a:bodyPr wrap="square" lIns="0" tIns="0" rIns="0" bIns="0" rtlCol="0" anchor="ctr"/>
-          <a:lstStyle/>
-          <a:p>
-            <a:pPr algn="ctr" indent="0" marL="0">
-              <a:buNone/>
-            </a:pPr>
-            <a:r>
-              <a:rPr lang="en-US" sz="1250" b="1" dirty="0">
-                <a:solidFill>
-                  <a:srgbClr val="1B2418"/>
-                </a:solidFill>
-                <a:latin typeface="Calibri" pitchFamily="34" charset="0"/>
-                <a:ea typeface="Calibri" pitchFamily="34" charset="-122"/>
-                <a:cs typeface="Calibri" pitchFamily="34" charset="-120"/>
-              </a:rPr>
-              <a:t>Amazon SQS</a:t>
-            </a:r>
-            <a:endParaRPr lang="en-US" sz="1250" dirty="0"/>
-          </a:p>
-        </p:txBody>
-      </p:sp>
-      <p:sp>
-        <p:nvSpPr>
-          <p:cNvPr id="16" name="Text 14"/>
-          <p:cNvSpPr/>
-          <p:nvPr/>
-        </p:nvSpPr>
-        <p:spPr>
-          <a:xfrm>
-            <a:off x="4828032" y="3401568"/>
-            <a:ext cx="1499616" cy="457200"/>
-          </a:xfrm>
-          <a:prstGeom prst="rect">
-            <a:avLst/>
-          </a:prstGeom>
-          <a:noFill/>
-          <a:ln/>
-        </p:spPr>
-        <p:txBody>
-          <a:bodyPr wrap="square" lIns="0" tIns="0" rIns="0" bIns="0" rtlCol="0" anchor="ctr"/>
-          <a:lstStyle/>
-          <a:p>
-            <a:pPr algn="ctr" indent="0" marL="0">
-              <a:buNone/>
-            </a:pPr>
-            <a:r>
-              <a:rPr lang="en-US" sz="900" dirty="0">
-                <a:solidFill>
-                  <a:srgbClr val="5F6E55"/>
-                </a:solidFill>
-                <a:latin typeface="Calibri" pitchFamily="34" charset="0"/>
-                <a:ea typeface="Calibri" pitchFamily="34" charset="-122"/>
-                <a:cs typeface="Calibri" pitchFamily="34" charset="-120"/>
-              </a:rPr>
-              <a:t>batched sends</a:t>
-            </a:r>
-            <a:endParaRPr lang="en-US" sz="900" dirty="0"/>
-          </a:p>
-        </p:txBody>
-      </p:sp>
-      <p:sp>
-        <p:nvSpPr>
-          <p:cNvPr id="17" name="Shape 15"/>
-          <p:cNvSpPr/>
-          <p:nvPr/>
-        </p:nvSpPr>
-        <p:spPr>
-          <a:xfrm>
-            <a:off x="6318504" y="3337560"/>
-            <a:ext cx="164592" cy="0"/>
-          </a:xfrm>
-          <a:prstGeom prst="line">
-            <a:avLst/>
-          </a:prstGeom>
-          <a:noFill/>
-          <a:ln w="20320">
+          <a:ln w="25400">
             <a:solidFill>
               <a:srgbClr val="6A9A52"/>
             </a:solidFill>
@@ -2087,26 +1741,26 @@
       </p:sp>
       <p:sp>
         <p:nvSpPr>
-          <p:cNvPr id="18" name="Shape 16"/>
-          <p:cNvSpPr/>
-          <p:nvPr/>
-        </p:nvSpPr>
-        <p:spPr>
-          <a:xfrm>
-            <a:off x="6492240" y="2651760"/>
-            <a:ext cx="1463040" cy="1371600"/>
+          <p:cNvPr id="8" name="Shape 6"/>
+          <p:cNvSpPr/>
+          <p:nvPr/>
+        </p:nvSpPr>
+        <p:spPr>
+          <a:xfrm>
+            <a:off x="3992728" y="2112264"/>
+            <a:ext cx="4206240" cy="658368"/>
           </a:xfrm>
           <a:prstGeom prst="roundRect">
             <a:avLst>
-              <a:gd name="adj" fmla="val 5333"/>
+              <a:gd name="adj" fmla="val 11111"/>
             </a:avLst>
           </a:prstGeom>
           <a:solidFill>
-            <a:srgbClr val="FFFFFF"/>
-          </a:solidFill>
-          <a:ln w="15240">
+            <a:srgbClr val="EEF3EA"/>
+          </a:solidFill>
+          <a:ln w="17780">
             <a:solidFill>
-              <a:srgbClr val="2C5F2D"/>
+              <a:srgbClr val="6A9A52"/>
             </a:solidFill>
             <a:prstDash val="solid"/>
           </a:ln>
@@ -2114,14 +1768,34 @@
       </p:sp>
       <p:sp>
         <p:nvSpPr>
-          <p:cNvPr id="19" name="Text 17"/>
-          <p:cNvSpPr/>
-          <p:nvPr/>
-        </p:nvSpPr>
-        <p:spPr>
-          <a:xfrm>
-            <a:off x="6446520" y="2907792"/>
-            <a:ext cx="1554480" cy="457200"/>
+          <p:cNvPr id="9" name="Shape 7"/>
+          <p:cNvSpPr/>
+          <p:nvPr/>
+        </p:nvSpPr>
+        <p:spPr>
+          <a:xfrm>
+            <a:off x="4193896" y="2359152"/>
+            <a:ext cx="164592" cy="164592"/>
+          </a:xfrm>
+          <a:prstGeom prst="ellipse">
+            <a:avLst/>
+          </a:prstGeom>
+          <a:solidFill>
+            <a:srgbClr val="6A9A52"/>
+          </a:solidFill>
+          <a:ln/>
+        </p:spPr>
+      </p:sp>
+      <p:sp>
+        <p:nvSpPr>
+          <p:cNvPr id="10" name="Text 8"/>
+          <p:cNvSpPr/>
+          <p:nvPr/>
+        </p:nvSpPr>
+        <p:spPr>
+          <a:xfrm>
+            <a:off x="4495648" y="2112264"/>
+            <a:ext cx="2194560" cy="658368"/>
           </a:xfrm>
           <a:prstGeom prst="rect">
             <a:avLst/>
@@ -2133,11 +1807,11 @@
           <a:bodyPr wrap="square" lIns="0" tIns="0" rIns="0" bIns="0" rtlCol="0" anchor="ctr"/>
           <a:lstStyle/>
           <a:p>
-            <a:pPr algn="ctr" indent="0" marL="0">
-              <a:buNone/>
-            </a:pPr>
-            <a:r>
-              <a:rPr lang="en-US" sz="1250" b="1" dirty="0">
+            <a:pPr indent="0" marL="0">
+              <a:buNone/>
+            </a:pPr>
+            <a:r>
+              <a:rPr lang="en-US" sz="1350" b="1" dirty="0">
                 <a:solidFill>
                   <a:srgbClr val="1B2418"/>
                 </a:solidFill>
@@ -2145,22 +1819,22 @@
                 <a:ea typeface="Calibri" pitchFamily="34" charset="-122"/>
                 <a:cs typeface="Calibri" pitchFamily="34" charset="-120"/>
               </a:rPr>
-              <a:t>AWS Lambda</a:t>
-            </a:r>
-            <a:endParaRPr lang="en-US" sz="1250" dirty="0"/>
-          </a:p>
-        </p:txBody>
-      </p:sp>
-      <p:sp>
-        <p:nvSpPr>
-          <p:cNvPr id="20" name="Text 18"/>
-          <p:cNvSpPr/>
-          <p:nvPr/>
-        </p:nvSpPr>
-        <p:spPr>
-          <a:xfrm>
-            <a:off x="6473952" y="3401568"/>
-            <a:ext cx="1499616" cy="457200"/>
+              <a:t>Fog node</a:t>
+            </a:r>
+            <a:endParaRPr lang="en-US" sz="1350" dirty="0"/>
+          </a:p>
+        </p:txBody>
+      </p:sp>
+      <p:sp>
+        <p:nvSpPr>
+          <p:cNvPr id="11" name="Text 9"/>
+          <p:cNvSpPr/>
+          <p:nvPr/>
+        </p:nvSpPr>
+        <p:spPr>
+          <a:xfrm>
+            <a:off x="6644488" y="2112264"/>
+            <a:ext cx="1463040" cy="658368"/>
           </a:xfrm>
           <a:prstGeom prst="rect">
             <a:avLst/>
@@ -2172,11 +1846,11 @@
           <a:bodyPr wrap="square" lIns="0" tIns="0" rIns="0" bIns="0" rtlCol="0" anchor="ctr"/>
           <a:lstStyle/>
           <a:p>
-            <a:pPr algn="ctr" indent="0" marL="0">
-              <a:buNone/>
-            </a:pPr>
-            <a:r>
-              <a:rPr lang="en-US" sz="900" dirty="0">
+            <a:pPr algn="r" indent="0" marL="0">
+              <a:buNone/>
+            </a:pPr>
+            <a:r>
+              <a:rPr lang="en-US" sz="950" dirty="0">
                 <a:solidFill>
                   <a:srgbClr val="5F6E55"/>
                 </a:solidFill>
@@ -2184,28 +1858,28 @@
                 <a:ea typeface="Calibri" pitchFamily="34" charset="-122"/>
                 <a:cs typeface="Calibri" pitchFamily="34" charset="-120"/>
               </a:rPr>
-              <a:t>nodejs20 ingest</a:t>
-            </a:r>
-            <a:endParaRPr lang="en-US" sz="900" dirty="0"/>
-          </a:p>
-        </p:txBody>
-      </p:sp>
-      <p:sp>
-        <p:nvSpPr>
-          <p:cNvPr id="21" name="Shape 19"/>
-          <p:cNvSpPr/>
-          <p:nvPr/>
-        </p:nvSpPr>
-        <p:spPr>
-          <a:xfrm>
-            <a:off x="7964424" y="3337560"/>
-            <a:ext cx="164592" cy="0"/>
+              <a:t>windows · fire alerts</a:t>
+            </a:r>
+            <a:endParaRPr lang="en-US" sz="950" dirty="0"/>
+          </a:p>
+        </p:txBody>
+      </p:sp>
+      <p:sp>
+        <p:nvSpPr>
+          <p:cNvPr id="12" name="Shape 10"/>
+          <p:cNvSpPr/>
+          <p:nvPr/>
+        </p:nvSpPr>
+        <p:spPr>
+          <a:xfrm>
+            <a:off x="6095848" y="2770632"/>
+            <a:ext cx="0" cy="219456"/>
           </a:xfrm>
           <a:prstGeom prst="line">
             <a:avLst/>
           </a:prstGeom>
           <a:noFill/>
-          <a:ln w="20320">
+          <a:ln w="25400">
             <a:solidFill>
               <a:srgbClr val="6A9A52"/>
             </a:solidFill>
@@ -2216,24 +1890,24 @@
       </p:sp>
       <p:sp>
         <p:nvSpPr>
-          <p:cNvPr id="22" name="Shape 20"/>
-          <p:cNvSpPr/>
-          <p:nvPr/>
-        </p:nvSpPr>
-        <p:spPr>
-          <a:xfrm>
-            <a:off x="8138160" y="2651760"/>
-            <a:ext cx="1463040" cy="1371600"/>
+          <p:cNvPr id="13" name="Shape 11"/>
+          <p:cNvSpPr/>
+          <p:nvPr/>
+        </p:nvSpPr>
+        <p:spPr>
+          <a:xfrm>
+            <a:off x="3992728" y="2990088"/>
+            <a:ext cx="4206240" cy="658368"/>
           </a:xfrm>
           <a:prstGeom prst="roundRect">
             <a:avLst>
-              <a:gd name="adj" fmla="val 5333"/>
+              <a:gd name="adj" fmla="val 11111"/>
             </a:avLst>
           </a:prstGeom>
           <a:solidFill>
-            <a:srgbClr val="FFFFFF"/>
-          </a:solidFill>
-          <a:ln w="15240">
+            <a:srgbClr val="EEF3EA"/>
+          </a:solidFill>
+          <a:ln w="17780">
             <a:solidFill>
               <a:srgbClr val="2C5F2D"/>
             </a:solidFill>
@@ -2243,14 +1917,34 @@
       </p:sp>
       <p:sp>
         <p:nvSpPr>
-          <p:cNvPr id="23" name="Text 21"/>
-          <p:cNvSpPr/>
-          <p:nvPr/>
-        </p:nvSpPr>
-        <p:spPr>
-          <a:xfrm>
-            <a:off x="8092440" y="2907792"/>
-            <a:ext cx="1554480" cy="457200"/>
+          <p:cNvPr id="14" name="Shape 12"/>
+          <p:cNvSpPr/>
+          <p:nvPr/>
+        </p:nvSpPr>
+        <p:spPr>
+          <a:xfrm>
+            <a:off x="4193896" y="3236976"/>
+            <a:ext cx="164592" cy="164592"/>
+          </a:xfrm>
+          <a:prstGeom prst="ellipse">
+            <a:avLst/>
+          </a:prstGeom>
+          <a:solidFill>
+            <a:srgbClr val="2C5F2D"/>
+          </a:solidFill>
+          <a:ln/>
+        </p:spPr>
+      </p:sp>
+      <p:sp>
+        <p:nvSpPr>
+          <p:cNvPr id="15" name="Text 13"/>
+          <p:cNvSpPr/>
+          <p:nvPr/>
+        </p:nvSpPr>
+        <p:spPr>
+          <a:xfrm>
+            <a:off x="4495648" y="2990088"/>
+            <a:ext cx="2194560" cy="658368"/>
           </a:xfrm>
           <a:prstGeom prst="rect">
             <a:avLst/>
@@ -2262,11 +1956,11 @@
           <a:bodyPr wrap="square" lIns="0" tIns="0" rIns="0" bIns="0" rtlCol="0" anchor="ctr"/>
           <a:lstStyle/>
           <a:p>
-            <a:pPr algn="ctr" indent="0" marL="0">
-              <a:buNone/>
-            </a:pPr>
-            <a:r>
-              <a:rPr lang="en-US" sz="1250" b="1" dirty="0">
+            <a:pPr indent="0" marL="0">
+              <a:buNone/>
+            </a:pPr>
+            <a:r>
+              <a:rPr lang="en-US" sz="1350" b="1" dirty="0">
                 <a:solidFill>
                   <a:srgbClr val="1B2418"/>
                 </a:solidFill>
@@ -2274,22 +1968,22 @@
                 <a:ea typeface="Calibri" pitchFamily="34" charset="-122"/>
                 <a:cs typeface="Calibri" pitchFamily="34" charset="-120"/>
               </a:rPr>
-              <a:t>DynamoDB</a:t>
-            </a:r>
-            <a:endParaRPr lang="en-US" sz="1250" dirty="0"/>
-          </a:p>
-        </p:txBody>
-      </p:sp>
-      <p:sp>
-        <p:nvSpPr>
-          <p:cNvPr id="24" name="Text 22"/>
-          <p:cNvSpPr/>
-          <p:nvPr/>
-        </p:nvSpPr>
-        <p:spPr>
-          <a:xfrm>
-            <a:off x="8119872" y="3401568"/>
-            <a:ext cx="1499616" cy="457200"/>
+              <a:t>Amazon SQS</a:t>
+            </a:r>
+            <a:endParaRPr lang="en-US" sz="1350" dirty="0"/>
+          </a:p>
+        </p:txBody>
+      </p:sp>
+      <p:sp>
+        <p:nvSpPr>
+          <p:cNvPr id="16" name="Text 14"/>
+          <p:cNvSpPr/>
+          <p:nvPr/>
+        </p:nvSpPr>
+        <p:spPr>
+          <a:xfrm>
+            <a:off x="6644488" y="2990088"/>
+            <a:ext cx="1463040" cy="658368"/>
           </a:xfrm>
           <a:prstGeom prst="rect">
             <a:avLst/>
@@ -2301,11 +1995,11 @@
           <a:bodyPr wrap="square" lIns="0" tIns="0" rIns="0" bIns="0" rtlCol="0" anchor="ctr"/>
           <a:lstStyle/>
           <a:p>
-            <a:pPr algn="ctr" indent="0" marL="0">
-              <a:buNone/>
-            </a:pPr>
-            <a:r>
-              <a:rPr lang="en-US" sz="900" dirty="0">
+            <a:pPr algn="r" indent="0" marL="0">
+              <a:buNone/>
+            </a:pPr>
+            <a:r>
+              <a:rPr lang="en-US" sz="950" dirty="0">
                 <a:solidFill>
                   <a:srgbClr val="5F6E55"/>
                 </a:solidFill>
@@ -2313,28 +2007,28 @@
                 <a:ea typeface="Calibri" pitchFamily="34" charset="-122"/>
                 <a:cs typeface="Calibri" pitchFamily="34" charset="-120"/>
               </a:rPr>
-              <a:t>window history</a:t>
-            </a:r>
-            <a:endParaRPr lang="en-US" sz="900" dirty="0"/>
-          </a:p>
-        </p:txBody>
-      </p:sp>
-      <p:sp>
-        <p:nvSpPr>
-          <p:cNvPr id="25" name="Shape 23"/>
-          <p:cNvSpPr/>
-          <p:nvPr/>
-        </p:nvSpPr>
-        <p:spPr>
-          <a:xfrm>
-            <a:off x="9610344" y="3337560"/>
-            <a:ext cx="164592" cy="0"/>
+              <a:t>batched sends</a:t>
+            </a:r>
+            <a:endParaRPr lang="en-US" sz="950" dirty="0"/>
+          </a:p>
+        </p:txBody>
+      </p:sp>
+      <p:sp>
+        <p:nvSpPr>
+          <p:cNvPr id="17" name="Shape 15"/>
+          <p:cNvSpPr/>
+          <p:nvPr/>
+        </p:nvSpPr>
+        <p:spPr>
+          <a:xfrm>
+            <a:off x="6095848" y="3648456"/>
+            <a:ext cx="0" cy="219456"/>
           </a:xfrm>
           <a:prstGeom prst="line">
             <a:avLst/>
           </a:prstGeom>
           <a:noFill/>
-          <a:ln w="20320">
+          <a:ln w="25400">
             <a:solidFill>
               <a:srgbClr val="6A9A52"/>
             </a:solidFill>
@@ -2345,24 +2039,322 @@
       </p:sp>
       <p:sp>
         <p:nvSpPr>
-          <p:cNvPr id="26" name="Shape 24"/>
-          <p:cNvSpPr/>
-          <p:nvPr/>
-        </p:nvSpPr>
-        <p:spPr>
-          <a:xfrm>
-            <a:off x="9784080" y="2651760"/>
-            <a:ext cx="1463040" cy="1371600"/>
+          <p:cNvPr id="18" name="Shape 16"/>
+          <p:cNvSpPr/>
+          <p:nvPr/>
+        </p:nvSpPr>
+        <p:spPr>
+          <a:xfrm>
+            <a:off x="3992728" y="3867912"/>
+            <a:ext cx="4206240" cy="658368"/>
           </a:xfrm>
           <a:prstGeom prst="roundRect">
             <a:avLst>
-              <a:gd name="adj" fmla="val 5333"/>
+              <a:gd name="adj" fmla="val 11111"/>
             </a:avLst>
           </a:prstGeom>
           <a:solidFill>
-            <a:srgbClr val="FFFFFF"/>
-          </a:solidFill>
-          <a:ln w="15240">
+            <a:srgbClr val="EEF3EA"/>
+          </a:solidFill>
+          <a:ln w="17780">
+            <a:solidFill>
+              <a:srgbClr val="2C5F2D"/>
+            </a:solidFill>
+            <a:prstDash val="solid"/>
+          </a:ln>
+        </p:spPr>
+      </p:sp>
+      <p:sp>
+        <p:nvSpPr>
+          <p:cNvPr id="19" name="Shape 17"/>
+          <p:cNvSpPr/>
+          <p:nvPr/>
+        </p:nvSpPr>
+        <p:spPr>
+          <a:xfrm>
+            <a:off x="4193896" y="4114800"/>
+            <a:ext cx="164592" cy="164592"/>
+          </a:xfrm>
+          <a:prstGeom prst="ellipse">
+            <a:avLst/>
+          </a:prstGeom>
+          <a:solidFill>
+            <a:srgbClr val="2C5F2D"/>
+          </a:solidFill>
+          <a:ln/>
+        </p:spPr>
+      </p:sp>
+      <p:sp>
+        <p:nvSpPr>
+          <p:cNvPr id="20" name="Text 18"/>
+          <p:cNvSpPr/>
+          <p:nvPr/>
+        </p:nvSpPr>
+        <p:spPr>
+          <a:xfrm>
+            <a:off x="4495648" y="3867912"/>
+            <a:ext cx="2194560" cy="658368"/>
+          </a:xfrm>
+          <a:prstGeom prst="rect">
+            <a:avLst/>
+          </a:prstGeom>
+          <a:noFill/>
+          <a:ln/>
+        </p:spPr>
+        <p:txBody>
+          <a:bodyPr wrap="square" lIns="0" tIns="0" rIns="0" bIns="0" rtlCol="0" anchor="ctr"/>
+          <a:lstStyle/>
+          <a:p>
+            <a:pPr indent="0" marL="0">
+              <a:buNone/>
+            </a:pPr>
+            <a:r>
+              <a:rPr lang="en-US" sz="1350" b="1" dirty="0">
+                <a:solidFill>
+                  <a:srgbClr val="1B2418"/>
+                </a:solidFill>
+                <a:latin typeface="Calibri" pitchFamily="34" charset="0"/>
+                <a:ea typeface="Calibri" pitchFamily="34" charset="-122"/>
+                <a:cs typeface="Calibri" pitchFamily="34" charset="-120"/>
+              </a:rPr>
+              <a:t>AWS Lambda</a:t>
+            </a:r>
+            <a:endParaRPr lang="en-US" sz="1350" dirty="0"/>
+          </a:p>
+        </p:txBody>
+      </p:sp>
+      <p:sp>
+        <p:nvSpPr>
+          <p:cNvPr id="21" name="Text 19"/>
+          <p:cNvSpPr/>
+          <p:nvPr/>
+        </p:nvSpPr>
+        <p:spPr>
+          <a:xfrm>
+            <a:off x="6644488" y="3867912"/>
+            <a:ext cx="1463040" cy="658368"/>
+          </a:xfrm>
+          <a:prstGeom prst="rect">
+            <a:avLst/>
+          </a:prstGeom>
+          <a:noFill/>
+          <a:ln/>
+        </p:spPr>
+        <p:txBody>
+          <a:bodyPr wrap="square" lIns="0" tIns="0" rIns="0" bIns="0" rtlCol="0" anchor="ctr"/>
+          <a:lstStyle/>
+          <a:p>
+            <a:pPr algn="r" indent="0" marL="0">
+              <a:buNone/>
+            </a:pPr>
+            <a:r>
+              <a:rPr lang="en-US" sz="950" dirty="0">
+                <a:solidFill>
+                  <a:srgbClr val="5F6E55"/>
+                </a:solidFill>
+                <a:latin typeface="Calibri" pitchFamily="34" charset="0"/>
+                <a:ea typeface="Calibri" pitchFamily="34" charset="-122"/>
+                <a:cs typeface="Calibri" pitchFamily="34" charset="-120"/>
+              </a:rPr>
+              <a:t>nodejs20 ingest</a:t>
+            </a:r>
+            <a:endParaRPr lang="en-US" sz="950" dirty="0"/>
+          </a:p>
+        </p:txBody>
+      </p:sp>
+      <p:sp>
+        <p:nvSpPr>
+          <p:cNvPr id="22" name="Shape 20"/>
+          <p:cNvSpPr/>
+          <p:nvPr/>
+        </p:nvSpPr>
+        <p:spPr>
+          <a:xfrm>
+            <a:off x="6095848" y="4526280"/>
+            <a:ext cx="0" cy="219456"/>
+          </a:xfrm>
+          <a:prstGeom prst="line">
+            <a:avLst/>
+          </a:prstGeom>
+          <a:noFill/>
+          <a:ln w="25400">
+            <a:solidFill>
+              <a:srgbClr val="6A9A52"/>
+            </a:solidFill>
+            <a:prstDash val="solid"/>
+            <a:tailEnd type="triangle"/>
+          </a:ln>
+        </p:spPr>
+      </p:sp>
+      <p:sp>
+        <p:nvSpPr>
+          <p:cNvPr id="23" name="Shape 21"/>
+          <p:cNvSpPr/>
+          <p:nvPr/>
+        </p:nvSpPr>
+        <p:spPr>
+          <a:xfrm>
+            <a:off x="3992728" y="4745736"/>
+            <a:ext cx="4206240" cy="658368"/>
+          </a:xfrm>
+          <a:prstGeom prst="roundRect">
+            <a:avLst>
+              <a:gd name="adj" fmla="val 11111"/>
+            </a:avLst>
+          </a:prstGeom>
+          <a:solidFill>
+            <a:srgbClr val="EEF3EA"/>
+          </a:solidFill>
+          <a:ln w="17780">
+            <a:solidFill>
+              <a:srgbClr val="2C5F2D"/>
+            </a:solidFill>
+            <a:prstDash val="solid"/>
+          </a:ln>
+        </p:spPr>
+      </p:sp>
+      <p:sp>
+        <p:nvSpPr>
+          <p:cNvPr id="24" name="Shape 22"/>
+          <p:cNvSpPr/>
+          <p:nvPr/>
+        </p:nvSpPr>
+        <p:spPr>
+          <a:xfrm>
+            <a:off x="4193896" y="4992624"/>
+            <a:ext cx="164592" cy="164592"/>
+          </a:xfrm>
+          <a:prstGeom prst="ellipse">
+            <a:avLst/>
+          </a:prstGeom>
+          <a:solidFill>
+            <a:srgbClr val="2C5F2D"/>
+          </a:solidFill>
+          <a:ln/>
+        </p:spPr>
+      </p:sp>
+      <p:sp>
+        <p:nvSpPr>
+          <p:cNvPr id="25" name="Text 23"/>
+          <p:cNvSpPr/>
+          <p:nvPr/>
+        </p:nvSpPr>
+        <p:spPr>
+          <a:xfrm>
+            <a:off x="4495648" y="4745736"/>
+            <a:ext cx="2194560" cy="658368"/>
+          </a:xfrm>
+          <a:prstGeom prst="rect">
+            <a:avLst/>
+          </a:prstGeom>
+          <a:noFill/>
+          <a:ln/>
+        </p:spPr>
+        <p:txBody>
+          <a:bodyPr wrap="square" lIns="0" tIns="0" rIns="0" bIns="0" rtlCol="0" anchor="ctr"/>
+          <a:lstStyle/>
+          <a:p>
+            <a:pPr indent="0" marL="0">
+              <a:buNone/>
+            </a:pPr>
+            <a:r>
+              <a:rPr lang="en-US" sz="1350" b="1" dirty="0">
+                <a:solidFill>
+                  <a:srgbClr val="1B2418"/>
+                </a:solidFill>
+                <a:latin typeface="Calibri" pitchFamily="34" charset="0"/>
+                <a:ea typeface="Calibri" pitchFamily="34" charset="-122"/>
+                <a:cs typeface="Calibri" pitchFamily="34" charset="-120"/>
+              </a:rPr>
+              <a:t>DynamoDB</a:t>
+            </a:r>
+            <a:endParaRPr lang="en-US" sz="1350" dirty="0"/>
+          </a:p>
+        </p:txBody>
+      </p:sp>
+      <p:sp>
+        <p:nvSpPr>
+          <p:cNvPr id="26" name="Text 24"/>
+          <p:cNvSpPr/>
+          <p:nvPr/>
+        </p:nvSpPr>
+        <p:spPr>
+          <a:xfrm>
+            <a:off x="6644488" y="4745736"/>
+            <a:ext cx="1463040" cy="658368"/>
+          </a:xfrm>
+          <a:prstGeom prst="rect">
+            <a:avLst/>
+          </a:prstGeom>
+          <a:noFill/>
+          <a:ln/>
+        </p:spPr>
+        <p:txBody>
+          <a:bodyPr wrap="square" lIns="0" tIns="0" rIns="0" bIns="0" rtlCol="0" anchor="ctr"/>
+          <a:lstStyle/>
+          <a:p>
+            <a:pPr algn="r" indent="0" marL="0">
+              <a:buNone/>
+            </a:pPr>
+            <a:r>
+              <a:rPr lang="en-US" sz="950" dirty="0">
+                <a:solidFill>
+                  <a:srgbClr val="5F6E55"/>
+                </a:solidFill>
+                <a:latin typeface="Calibri" pitchFamily="34" charset="0"/>
+                <a:ea typeface="Calibri" pitchFamily="34" charset="-122"/>
+                <a:cs typeface="Calibri" pitchFamily="34" charset="-120"/>
+              </a:rPr>
+              <a:t>window history</a:t>
+            </a:r>
+            <a:endParaRPr lang="en-US" sz="950" dirty="0"/>
+          </a:p>
+        </p:txBody>
+      </p:sp>
+      <p:sp>
+        <p:nvSpPr>
+          <p:cNvPr id="27" name="Shape 25"/>
+          <p:cNvSpPr/>
+          <p:nvPr/>
+        </p:nvSpPr>
+        <p:spPr>
+          <a:xfrm>
+            <a:off x="6095848" y="5404104"/>
+            <a:ext cx="0" cy="219456"/>
+          </a:xfrm>
+          <a:prstGeom prst="line">
+            <a:avLst/>
+          </a:prstGeom>
+          <a:noFill/>
+          <a:ln w="25400">
+            <a:solidFill>
+              <a:srgbClr val="6A9A52"/>
+            </a:solidFill>
+            <a:prstDash val="solid"/>
+            <a:tailEnd type="triangle"/>
+          </a:ln>
+        </p:spPr>
+      </p:sp>
+      <p:sp>
+        <p:nvSpPr>
+          <p:cNvPr id="28" name="Shape 26"/>
+          <p:cNvSpPr/>
+          <p:nvPr/>
+        </p:nvSpPr>
+        <p:spPr>
+          <a:xfrm>
+            <a:off x="3992728" y="5623560"/>
+            <a:ext cx="4206240" cy="658368"/>
+          </a:xfrm>
+          <a:prstGeom prst="roundRect">
+            <a:avLst>
+              <a:gd name="adj" fmla="val 11111"/>
+            </a:avLst>
+          </a:prstGeom>
+          <a:solidFill>
+            <a:srgbClr val="EEF3EA"/>
+          </a:solidFill>
+          <a:ln w="17780">
             <a:solidFill>
               <a:srgbClr val="3F7C3F"/>
             </a:solidFill>
@@ -2372,14 +2364,34 @@
       </p:sp>
       <p:sp>
         <p:nvSpPr>
-          <p:cNvPr id="27" name="Text 25"/>
-          <p:cNvSpPr/>
-          <p:nvPr/>
-        </p:nvSpPr>
-        <p:spPr>
-          <a:xfrm>
-            <a:off x="9738360" y="2907792"/>
-            <a:ext cx="1554480" cy="457200"/>
+          <p:cNvPr id="29" name="Shape 27"/>
+          <p:cNvSpPr/>
+          <p:nvPr/>
+        </p:nvSpPr>
+        <p:spPr>
+          <a:xfrm>
+            <a:off x="4193896" y="5870448"/>
+            <a:ext cx="164592" cy="164592"/>
+          </a:xfrm>
+          <a:prstGeom prst="ellipse">
+            <a:avLst/>
+          </a:prstGeom>
+          <a:solidFill>
+            <a:srgbClr val="3F7C3F"/>
+          </a:solidFill>
+          <a:ln/>
+        </p:spPr>
+      </p:sp>
+      <p:sp>
+        <p:nvSpPr>
+          <p:cNvPr id="30" name="Text 28"/>
+          <p:cNvSpPr/>
+          <p:nvPr/>
+        </p:nvSpPr>
+        <p:spPr>
+          <a:xfrm>
+            <a:off x="4495648" y="5623560"/>
+            <a:ext cx="2194560" cy="658368"/>
           </a:xfrm>
           <a:prstGeom prst="rect">
             <a:avLst/>
@@ -2391,11 +2403,11 @@
           <a:bodyPr wrap="square" lIns="0" tIns="0" rIns="0" bIns="0" rtlCol="0" anchor="ctr"/>
           <a:lstStyle/>
           <a:p>
-            <a:pPr algn="ctr" indent="0" marL="0">
-              <a:buNone/>
-            </a:pPr>
-            <a:r>
-              <a:rPr lang="en-US" sz="1250" b="1" dirty="0">
+            <a:pPr indent="0" marL="0">
+              <a:buNone/>
+            </a:pPr>
+            <a:r>
+              <a:rPr lang="en-US" sz="1350" b="1" dirty="0">
                 <a:solidFill>
                   <a:srgbClr val="1B2418"/>
                 </a:solidFill>
@@ -2405,20 +2417,20 @@
               </a:rPr>
               <a:t>API GW + S3</a:t>
             </a:r>
-            <a:endParaRPr lang="en-US" sz="1250" dirty="0"/>
-          </a:p>
-        </p:txBody>
-      </p:sp>
-      <p:sp>
-        <p:nvSpPr>
-          <p:cNvPr id="28" name="Text 26"/>
-          <p:cNvSpPr/>
-          <p:nvPr/>
-        </p:nvSpPr>
-        <p:spPr>
-          <a:xfrm>
-            <a:off x="9765792" y="3401568"/>
-            <a:ext cx="1499616" cy="457200"/>
+            <a:endParaRPr lang="en-US" sz="1350" dirty="0"/>
+          </a:p>
+        </p:txBody>
+      </p:sp>
+      <p:sp>
+        <p:nvSpPr>
+          <p:cNvPr id="31" name="Text 29"/>
+          <p:cNvSpPr/>
+          <p:nvPr/>
+        </p:nvSpPr>
+        <p:spPr>
+          <a:xfrm>
+            <a:off x="6644488" y="5623560"/>
+            <a:ext cx="1463040" cy="658368"/>
           </a:xfrm>
           <a:prstGeom prst="rect">
             <a:avLst/>
@@ -2430,11 +2442,11 @@
           <a:bodyPr wrap="square" lIns="0" tIns="0" rIns="0" bIns="0" rtlCol="0" anchor="ctr"/>
           <a:lstStyle/>
           <a:p>
-            <a:pPr algn="ctr" indent="0" marL="0">
-              <a:buNone/>
-            </a:pPr>
-            <a:r>
-              <a:rPr lang="en-US" sz="900" dirty="0">
+            <a:pPr algn="r" indent="0" marL="0">
+              <a:buNone/>
+            </a:pPr>
+            <a:r>
+              <a:rPr lang="en-US" sz="950" dirty="0">
                 <a:solidFill>
                   <a:srgbClr val="5F6E55"/>
                 </a:solidFill>
@@ -2444,20 +2456,20 @@
               </a:rPr>
               <a:t>0–4 risk dial</a:t>
             </a:r>
-            <a:endParaRPr lang="en-US" sz="900" dirty="0"/>
-          </a:p>
-        </p:txBody>
-      </p:sp>
-      <p:sp>
-        <p:nvSpPr>
-          <p:cNvPr id="29" name="Text 27"/>
-          <p:cNvSpPr/>
-          <p:nvPr/>
-        </p:nvSpPr>
-        <p:spPr>
-          <a:xfrm>
-            <a:off x="640080" y="5257800"/>
-            <a:ext cx="10972800" cy="731520"/>
+            <a:endParaRPr lang="en-US" sz="950" dirty="0"/>
+          </a:p>
+        </p:txBody>
+      </p:sp>
+      <p:sp>
+        <p:nvSpPr>
+          <p:cNvPr id="32" name="Text 30"/>
+          <p:cNvSpPr/>
+          <p:nvPr/>
+        </p:nvSpPr>
+        <p:spPr>
+          <a:xfrm>
+            <a:off x="2438248" y="1234440"/>
+            <a:ext cx="1371600" cy="365760"/>
           </a:xfrm>
           <a:prstGeom prst="rect">
             <a:avLst/>
@@ -2469,7 +2481,85 @@
           <a:bodyPr wrap="square" rtlCol="0" anchor="ctr"/>
           <a:lstStyle/>
           <a:p>
-            <a:pPr algn="ctr" indent="0" marL="0">
+            <a:pPr algn="r" indent="0" marL="0">
+              <a:buNone/>
+            </a:pPr>
+            <a:r>
+              <a:rPr lang="en-US" sz="1100" b="1" spc="200" kern="0" dirty="0">
+                <a:solidFill>
+                  <a:srgbClr val="6A9A52"/>
+                </a:solidFill>
+                <a:latin typeface="Calibri" pitchFamily="34" charset="0"/>
+                <a:ea typeface="Calibri" pitchFamily="34" charset="-122"/>
+                <a:cs typeface="Calibri" pitchFamily="34" charset="-120"/>
+              </a:rPr>
+              <a:t>EDGE</a:t>
+            </a:r>
+            <a:endParaRPr lang="en-US" sz="1100" dirty="0"/>
+          </a:p>
+        </p:txBody>
+      </p:sp>
+      <p:sp>
+        <p:nvSpPr>
+          <p:cNvPr id="33" name="Text 31"/>
+          <p:cNvSpPr/>
+          <p:nvPr/>
+        </p:nvSpPr>
+        <p:spPr>
+          <a:xfrm>
+            <a:off x="2438248" y="2990088"/>
+            <a:ext cx="1371600" cy="365760"/>
+          </a:xfrm>
+          <a:prstGeom prst="rect">
+            <a:avLst/>
+          </a:prstGeom>
+          <a:noFill/>
+          <a:ln/>
+        </p:spPr>
+        <p:txBody>
+          <a:bodyPr wrap="square" rtlCol="0" anchor="ctr"/>
+          <a:lstStyle/>
+          <a:p>
+            <a:pPr algn="r" indent="0" marL="0">
+              <a:buNone/>
+            </a:pPr>
+            <a:r>
+              <a:rPr lang="en-US" sz="1100" b="1" spc="200" kern="0" dirty="0">
+                <a:solidFill>
+                  <a:srgbClr val="2C5F2D"/>
+                </a:solidFill>
+                <a:latin typeface="Calibri" pitchFamily="34" charset="0"/>
+                <a:ea typeface="Calibri" pitchFamily="34" charset="-122"/>
+                <a:cs typeface="Calibri" pitchFamily="34" charset="-120"/>
+              </a:rPr>
+              <a:t>CLOUD</a:t>
+            </a:r>
+            <a:endParaRPr lang="en-US" sz="1100" dirty="0"/>
+          </a:p>
+        </p:txBody>
+      </p:sp>
+      <p:sp>
+        <p:nvSpPr>
+          <p:cNvPr id="34" name="Text 32"/>
+          <p:cNvSpPr/>
+          <p:nvPr/>
+        </p:nvSpPr>
+        <p:spPr>
+          <a:xfrm>
+            <a:off x="8656168" y="2743200"/>
+            <a:ext cx="3291840" cy="2194560"/>
+          </a:xfrm>
+          <a:prstGeom prst="rect">
+            <a:avLst/>
+          </a:prstGeom>
+          <a:noFill/>
+          <a:ln/>
+        </p:spPr>
+        <p:txBody>
+          <a:bodyPr wrap="square" rtlCol="0" anchor="ctr"/>
+          <a:lstStyle/>
+          <a:p>
+            <a:pPr indent="0" marL="0">
               <a:buNone/>
             </a:pPr>
             <a:r>
@@ -3135,12 +3225,12 @@
         </p:nvSpPr>
         <p:spPr>
           <a:xfrm>
-            <a:off x="640080" y="1874520"/>
-            <a:ext cx="4937760" cy="4160520"/>
+            <a:off x="731520" y="1920240"/>
+            <a:ext cx="10698480" cy="1965960"/>
           </a:xfrm>
           <a:prstGeom prst="roundRect">
             <a:avLst>
-              <a:gd name="adj" fmla="val 2198"/>
+              <a:gd name="adj" fmla="val 4651"/>
             </a:avLst>
           </a:prstGeom>
           <a:solidFill>
@@ -3162,7 +3252,7 @@
         </p:nvSpPr>
         <p:spPr>
           <a:xfrm>
-            <a:off x="960120" y="2103120"/>
+            <a:off x="1005840" y="2103120"/>
             <a:ext cx="3657600" cy="457200"/>
           </a:xfrm>
           <a:prstGeom prst="rect">
@@ -3201,8 +3291,8 @@
         </p:nvSpPr>
         <p:spPr>
           <a:xfrm>
-            <a:off x="960120" y="2651760"/>
-            <a:ext cx="4343400" cy="3200400"/>
+            <a:off x="1005840" y="2578608"/>
+            <a:ext cx="9966960" cy="1188720"/>
           </a:xfrm>
           <a:prstGeom prst="rect">
             <a:avLst/>
@@ -3216,12 +3306,12 @@
           <a:p>
             <a:pPr indent="0" marL="0">
               <a:lnSpc>
-                <a:spcPct val="112000"/>
+                <a:spcPct val="105000"/>
               </a:lnSpc>
               <a:buNone/>
             </a:pPr>
             <a:r>
-              <a:rPr lang="en-US" sz="1350" dirty="0">
+              <a:rPr lang="en-US" sz="1300" dirty="0">
                 <a:solidFill>
                   <a:srgbClr val="1B2418"/>
                 </a:solidFill>
@@ -3231,7 +3321,7 @@
               </a:rPr>
               <a:t>Locally the pipeline signs its queue and database calls with the emulator's dummy credentials, and it decided when to use them by checking whether an AWS access-key variable was present. But real AWS injects that exact variable into every function it runs — so in production every call would be signed with incomplete credentials and rejected. All 95 tests stayed green; nothing could fail until the first real deployment.</a:t>
             </a:r>
-            <a:endParaRPr lang="en-US" sz="1350" dirty="0"/>
+            <a:endParaRPr lang="en-US" sz="1300" dirty="0"/>
           </a:p>
         </p:txBody>
       </p:sp>
@@ -3243,12 +3333,12 @@
         </p:nvSpPr>
         <p:spPr>
           <a:xfrm>
-            <a:off x="6611112" y="1874520"/>
-            <a:ext cx="4937760" cy="4160520"/>
+            <a:off x="731520" y="4041648"/>
+            <a:ext cx="10698480" cy="1965960"/>
           </a:xfrm>
           <a:prstGeom prst="roundRect">
             <a:avLst>
-              <a:gd name="adj" fmla="val 2198"/>
+              <a:gd name="adj" fmla="val 4651"/>
             </a:avLst>
           </a:prstGeom>
           <a:solidFill>
@@ -3270,7 +3360,7 @@
         </p:nvSpPr>
         <p:spPr>
           <a:xfrm>
-            <a:off x="6931152" y="2103120"/>
+            <a:off x="1005840" y="4224528"/>
             <a:ext cx="3657600" cy="457200"/>
           </a:xfrm>
           <a:prstGeom prst="rect">
@@ -3309,8 +3399,8 @@
         </p:nvSpPr>
         <p:spPr>
           <a:xfrm>
-            <a:off x="6931152" y="2651760"/>
-            <a:ext cx="4343400" cy="3200400"/>
+            <a:off x="1005840" y="4700016"/>
+            <a:ext cx="9966960" cy="1188720"/>
           </a:xfrm>
           <a:prstGeom prst="rect">
             <a:avLst/>
@@ -3324,12 +3414,12 @@
           <a:p>
             <a:pPr indent="0" marL="0">
               <a:lnSpc>
-                <a:spcPct val="112000"/>
+                <a:spcPct val="105000"/>
               </a:lnSpc>
               <a:buNone/>
             </a:pPr>
             <a:r>
-              <a:rPr lang="en-US" sz="1350" dirty="0">
+              <a:rPr lang="en-US" sz="1300" dirty="0">
                 <a:solidFill>
                   <a:srgbClr val="1B2418"/>
                 </a:solidFill>
@@ -3339,29 +3429,9 @@
               </a:rPr>
               <a:t>Gate on a signal that only exists locally: the emulator's endpoint address. On real AWS it is absent, so the platform's own credentials take over automatically. New tests now pin that behaviour down in both profiles.</a:t>
             </a:r>
-            <a:endParaRPr lang="en-US" sz="1350" dirty="0"/>
-          </a:p>
-        </p:txBody>
-      </p:sp>
-      <p:sp>
-        <p:nvSpPr>
-          <p:cNvPr id="9" name="Shape 7"/>
-          <p:cNvSpPr/>
-          <p:nvPr/>
-        </p:nvSpPr>
-        <p:spPr>
-          <a:xfrm>
-            <a:off x="5669280" y="3703320"/>
-            <a:ext cx="841248" cy="512064"/>
-          </a:xfrm>
-          <a:prstGeom prst="rightArrow">
-            <a:avLst/>
-          </a:prstGeom>
-          <a:solidFill>
-            <a:srgbClr val="2C5F2D"/>
-          </a:solidFill>
-          <a:ln/>
-        </p:spPr>
+            <a:endParaRPr lang="en-US" sz="1300" dirty="0"/>
+          </a:p>
+        </p:txBody>
       </p:sp>
     </p:spTree>
   </p:cSld>

</xml_diff>